<commit_message>
Quitar párrafos cortables del guion y de las notas del orador; ajustar tiempos
Co-Authored-By: Claude Opus 5.5 <noreply@anthropic.com>
Claude-Session: https://claude.ai/code/session_01FbQnxmXCWMLiXX8iQo1dcG
</commit_message>
<xml_diff>
--- a/Smith2022_presentacion_v4.pptx
+++ b/Smith2022_presentacion_v4.pptx
@@ -596,7 +596,7 @@
           <a:lstStyle/>
           <a:p>
             <a:r>
-              <a:t>[0:20–1:15]</a:t>
+              <a:t>[0:20–1:05]</a:t>
             </a:r>
           </a:p>
           <a:p>
@@ -607,11 +607,6 @@
           <a:p>
             <a:r>
               <a:t>El caso es el Tata Memorial Hospital: concebido en 1932, abierto en 1941, y seguido hasta 1963. El método es archivo más entrevistas: los archivos Tata, el Instituto Tata de Investigación Fundamental, la British Library y Yale, y conversaciones con descendientes de los protagonistas.</a:t>
-            </a:r>
-          </a:p>
-          <a:p>
-            <a:r>
-              <a:t>[Cortable] Abajo ven a Homi Bhabha presidiendo en Ginebra, en 1955, la conferencia Átomos para la Paz: el átomo y el cáncer se cruzan en la misma red.</a:t>
             </a:r>
           </a:p>
           <a:p>
@@ -707,7 +702,7 @@
           <a:lstStyle/>
           <a:p>
             <a:r>
-              <a:t>[1:15–2:40]</a:t>
+              <a:t>[1:05–2:30]</a:t>
             </a:r>
           </a:p>
           <a:p>
@@ -818,17 +813,12 @@
           <a:lstStyle/>
           <a:p>
             <a:r>
-              <a:t>[2:40–4:00]</a:t>
+              <a:t>[2:30–3:40]</a:t>
             </a:r>
           </a:p>
           <a:p>
             <a:r>
               <a:t>Ahora, la conexión con mi práctica. En 1957 los Tata donaron el hospital al Ministerio de Salud; en 1962 Bhabha lo pasó al Departamento de Energía Atómica, y en 1963 se creó el Centro de Medicina de la Radiación, que le producía los radioisótopos. Estado, isótopos, hospital.</a:t>
-            </a:r>
-          </a:p>
-          <a:p>
-            <a:r>
-              <a:t>[Cortable] Ya en 1947, el jefe de radiología, el doctor Mody, decía que la esperanza estaba en la «promesa» de los radioisótopos: ahí nace mi disciplina.</a:t>
             </a:r>
           </a:p>
           <a:p>
@@ -929,17 +919,12 @@
           <a:lstStyle/>
           <a:p>
             <a:r>
-              <a:t>[4:00–4:40]</a:t>
+              <a:t>[3:40–4:10]</a:t>
             </a:r>
           </a:p>
           <a:p>
             <a:r>
               <a:t>El lente que me deja: la validez de una terapia es un logro sociotécnico, no un dato. Esta es la nota de FALP sobre nuestra visita a la CCHEN. Para Smith sería un documento de archivo: una alianza en formación, como la carta de Naidu a Bhabha en 1945. Para mí es el presente.</a:t>
-            </a:r>
-          </a:p>
-          <a:p>
-            <a:r>
-              <a:t>[Cortable] Y fíjense en los botones de arriba: «Solicita tu hora», «Dona aquí». La filantropía y el mercado en la misma página.</a:t>
             </a:r>
           </a:p>
           <a:p>

</xml_diff>

<commit_message>
Diapositiva 2: quitar foto de Bhabha y agrandar el Tata Memorial
Co-Authored-By: Claude Opus 5.5 <noreply@anthropic.com>
Claude-Session: https://claude.ai/code/session_01FbQnxmXCWMLiXX8iQo1dcG
</commit_message>
<xml_diff>
--- a/Smith2022_presentacion_v4.pptx
+++ b/Smith2022_presentacion_v4.pptx
@@ -616,7 +616,7 @@
           </a:p>
           <a:p>
             <a:r>
-              <a:t>Créditos fotos: Tata Memorial Hospital (Ad baheti, 2022, CC0) · Homi J. Bhabha presidiendo la Conferencia Átomos para la Paz, Ginebra 1955 (IAEA Imagebank, CC BY-SA 2.0). Vía Wikimedia Commons.</a:t>
+              <a:t>Crédito foto: Tata Memorial Hospital (Ad baheti, 2022, CC0), vía Wikimedia Commons.</a:t>
             </a:r>
           </a:p>
         </p:txBody>
@@ -1989,7 +1989,7 @@
         <p:spPr>
           <a:xfrm>
             <a:off x="3977640" y="1051560"/>
-            <a:ext cx="4800600" cy="2834640"/>
+            <a:ext cx="4800600" cy="4572000"/>
           </a:xfrm>
           <a:prstGeom prst="rect">
             <a:avLst/>
@@ -2016,7 +2016,7 @@
         </p:nvSpPr>
         <p:spPr>
           <a:xfrm>
-            <a:off x="3977640" y="3931920"/>
+            <a:off x="3977640" y="5715000"/>
             <a:ext cx="4800600" cy="292608"/>
           </a:xfrm>
           <a:prstGeom prst="rect">
@@ -2042,81 +2042,6 @@
                 <a:cs typeface="Times New Roman" pitchFamily="34" charset="-120"/>
               </a:rPr>
               <a:t>Bombay · Tata Memorial Hospital</a:t>
-            </a:r>
-            <a:endParaRPr lang="en-US" sz="1400" dirty="0"/>
-          </a:p>
-        </p:txBody>
-      </p:sp>
-      <p:pic>
-        <p:nvPicPr>
-          <p:cNvPr id="91" name="Foto Bhabha" descr="Homi J. Bhabha, Ginebra 1955"/>
-          <p:cNvPicPr>
-            <a:picLocks noChangeAspect="1"/>
-          </p:cNvPicPr>
-          <p:nvPr/>
-        </p:nvPicPr>
-        <p:blipFill>
-          <a:blip r:embed="rId91"/>
-          <a:stretch>
-            <a:fillRect/>
-          </a:stretch>
-        </p:blipFill>
-        <p:spPr>
-          <a:xfrm>
-            <a:off x="6309360" y="4343400"/>
-            <a:ext cx="2468880" cy="1965960"/>
-          </a:xfrm>
-          <a:prstGeom prst="rect">
-            <a:avLst/>
-          </a:prstGeom>
-          <a:ln w="12700">
-            <a:solidFill>
-              <a:srgbClr val="E0B000"/>
-            </a:solidFill>
-          </a:ln>
-          <a:effectLst>
-            <a:outerShdw sx="100000" sy="100000" kx="0" ky="0" algn="bl" rotWithShape="0" blurRad="25400" dist="25400" dir="2700000">
-              <a:srgbClr val="000000">
-                <a:alpha val="90000"/>
-              </a:srgbClr>
-            </a:outerShdw>
-          </a:effectLst>
-        </p:spPr>
-      </p:pic>
-      <p:sp>
-        <p:nvSpPr>
-          <p:cNvPr id="92" name="Caption Bhabha"/>
-          <p:cNvSpPr txBox="1"/>
-          <p:nvPr/>
-        </p:nvSpPr>
-        <p:spPr>
-          <a:xfrm>
-            <a:off x="3977640" y="5669280"/>
-            <a:ext cx="2194560" cy="640080"/>
-          </a:xfrm>
-          <a:prstGeom prst="rect">
-            <a:avLst/>
-          </a:prstGeom>
-          <a:noFill/>
-          <a:ln/>
-        </p:spPr>
-        <p:txBody>
-          <a:bodyPr wrap="square" lIns="0" tIns="0" rIns="0" bIns="0" rtlCol="0" anchor="ctr"/>
-          <a:lstStyle/>
-          <a:p>
-            <a:pPr algn="r" indent="0" marL="0">
-              <a:buNone/>
-            </a:pPr>
-            <a:r>
-              <a:rPr lang="en-US" sz="1400" dirty="0">
-                <a:solidFill>
-                  <a:srgbClr val="FFDD33"/>
-                </a:solidFill>
-                <a:latin typeface="Times New Roman" pitchFamily="34" charset="0"/>
-                <a:ea typeface="Times New Roman" pitchFamily="34" charset="-122"/>
-                <a:cs typeface="Times New Roman" pitchFamily="34" charset="-120"/>
-              </a:rPr>
-              <a:t>Homi Bhabha · Ginebra, 1955</a:t>
             </a:r>
             <a:endParaRPr lang="en-US" sz="1400" dirty="0"/>
           </a:p>

</xml_diff>